<commit_message>
Personalize: Dr. Dhiaa as supervisor; team-only mentions; @iau emails
- Student emails switched to {student_id}@iau.edu.sa format
- All course instructors set to Dr. Dhiaa (course supervisor)
- All non-team personal names removed (replaced with generic placeholders
  like 'Demo Student' / 'Test Student' for screenshot scenarios)
- Report, presentation title slide, README, and test guide updated
- Both server binaries rebuilt with new seed data
- All 21 screenshots re-captured against the corrected database
</commit_message>
<xml_diff>
--- a/Report/CS516_Presentation.pptx
+++ b/Report/CS516_Presentation.pptx
@@ -3626,7 +3626,7 @@
                 </a:solidFill>
                 <a:latin typeface="Calibri"/>
               </a:rPr>
-              <a:t>Mrs. Sarah Alissa</a:t>
+              <a:t>Dr. Dhiaa</a:t>
             </a:r>
           </a:p>
         </p:txBody>
@@ -6241,7 +6241,7 @@
         <p:spPr>
           <a:xfrm>
             <a:off x="6537960" y="2468880"/>
-            <a:ext cx="5120640" cy="2732711"/>
+            <a:ext cx="5120640" cy="2672724"/>
           </a:xfrm>
           <a:prstGeom prst="rect">
             <a:avLst/>
@@ -9476,7 +9476,7 @@
       </p:pic>
       <p:pic>
         <p:nvPicPr>
-          <p:cNvPr id="10" name="Picture 9" descr="py_09_attendance_report.png"/>
+          <p:cNvPr id="10" name="Picture 9" descr="py_10_attendance_summary.png"/>
           <p:cNvPicPr>
             <a:picLocks noChangeAspect="1"/>
           </p:cNvPicPr>
@@ -10427,7 +10427,7 @@
         <p:spPr>
           <a:xfrm>
             <a:off x="4251960" y="1234440"/>
-            <a:ext cx="3840480" cy="2049533"/>
+            <a:ext cx="3840480" cy="2004543"/>
           </a:xfrm>
           <a:prstGeom prst="rect">
             <a:avLst/>

</xml_diff>